<commit_message>
test(e2e): cover inserted bar-chart labels, 3D list SmartArt, fix chart-gallery anchor
The chart-gallery fixture's title-anchor shape was a 1px-wide 24pt text box, so
its title rendered one glyph per line next to the chart and looked like a broken
chart title. Give it a real size and move it below the chart frame.

Co-Authored-By: Claude Sonnet 5 <noreply@anthropic.com>
</commit_message>
<xml_diff>
--- a/viewers/pptx/e2e/fixtures/chart-gallery.pptx
+++ b/viewers/pptx/e2e/fixtures/chart-gallery.pptx
@@ -3582,8 +3582,8 @@
         </p:nvSpPr>
         <p:spPr>
           <a:xfrm>
-            <a:off x="0" y="0"/>
-            <a:ext cx="9525" cy="9525"/>
+            <a:off x="0" y="4762500"/>
+            <a:ext cx="3048000" cy="285750"/>
           </a:xfrm>
           <a:prstGeom prst="rect">
             <a:avLst/>
@@ -3646,14 +3646,14 @@
       </p:grpSpPr>
       <p:sp>
         <p:nvSpPr>
-          <p:cNvPr id="10" name="Rectangle 10"/>
+          <p:cNvPr id="2" name="Rectangle 10"/>
           <p:cNvSpPr txBox="0"/>
           <p:nvPr/>
         </p:nvSpPr>
         <p:spPr>
           <a:xfrm>
-            <a:off x="0" y="0"/>
-            <a:ext cx="9525" cy="9525"/>
+            <a:off x="0" y="4762500"/>
+            <a:ext cx="3048000" cy="285750"/>
           </a:xfrm>
           <a:prstGeom prst="rect">
             <a:avLst/>
@@ -3716,14 +3716,14 @@
       </p:grpSpPr>
       <p:sp>
         <p:nvSpPr>
-          <p:cNvPr id="11" name="Rectangle 11"/>
+          <p:cNvPr id="2" name="Rectangle 11"/>
           <p:cNvSpPr txBox="0"/>
           <p:nvPr/>
         </p:nvSpPr>
         <p:spPr>
           <a:xfrm>
-            <a:off x="0" y="0"/>
-            <a:ext cx="9525" cy="9525"/>
+            <a:off x="0" y="4762500"/>
+            <a:ext cx="3048000" cy="285750"/>
           </a:xfrm>
           <a:prstGeom prst="rect">
             <a:avLst/>
@@ -3786,14 +3786,14 @@
       </p:grpSpPr>
       <p:sp>
         <p:nvSpPr>
-          <p:cNvPr id="12" name="Rectangle 12"/>
+          <p:cNvPr id="2" name="Rectangle 12"/>
           <p:cNvSpPr txBox="0"/>
           <p:nvPr/>
         </p:nvSpPr>
         <p:spPr>
           <a:xfrm>
-            <a:off x="0" y="0"/>
-            <a:ext cx="9525" cy="9525"/>
+            <a:off x="0" y="4762500"/>
+            <a:ext cx="3048000" cy="285750"/>
           </a:xfrm>
           <a:prstGeom prst="rect">
             <a:avLst/>
@@ -3856,14 +3856,14 @@
       </p:grpSpPr>
       <p:sp>
         <p:nvSpPr>
-          <p:cNvPr id="13" name="Rectangle 13"/>
+          <p:cNvPr id="2" name="Rectangle 13"/>
           <p:cNvSpPr txBox="0"/>
           <p:nvPr/>
         </p:nvSpPr>
         <p:spPr>
           <a:xfrm>
-            <a:off x="0" y="0"/>
-            <a:ext cx="9525" cy="9525"/>
+            <a:off x="0" y="4762500"/>
+            <a:ext cx="3048000" cy="285750"/>
           </a:xfrm>
           <a:prstGeom prst="rect">
             <a:avLst/>
@@ -3926,14 +3926,14 @@
       </p:grpSpPr>
       <p:sp>
         <p:nvSpPr>
-          <p:cNvPr id="14" name="Rectangle 14"/>
+          <p:cNvPr id="2" name="Rectangle 14"/>
           <p:cNvSpPr txBox="0"/>
           <p:nvPr/>
         </p:nvSpPr>
         <p:spPr>
           <a:xfrm>
-            <a:off x="0" y="0"/>
-            <a:ext cx="9525" cy="9525"/>
+            <a:off x="0" y="4762500"/>
+            <a:ext cx="3048000" cy="285750"/>
           </a:xfrm>
           <a:prstGeom prst="rect">
             <a:avLst/>
@@ -3996,14 +3996,14 @@
       </p:grpSpPr>
       <p:sp>
         <p:nvSpPr>
-          <p:cNvPr id="15" name="Rectangle 15"/>
+          <p:cNvPr id="2" name="Rectangle 15"/>
           <p:cNvSpPr txBox="0"/>
           <p:nvPr/>
         </p:nvSpPr>
         <p:spPr>
           <a:xfrm>
-            <a:off x="0" y="0"/>
-            <a:ext cx="9525" cy="9525"/>
+            <a:off x="0" y="4762500"/>
+            <a:ext cx="3048000" cy="285750"/>
           </a:xfrm>
           <a:prstGeom prst="rect">
             <a:avLst/>
@@ -4066,14 +4066,14 @@
       </p:grpSpPr>
       <p:sp>
         <p:nvSpPr>
-          <p:cNvPr id="16" name="Rectangle 16"/>
+          <p:cNvPr id="2" name="Rectangle 16"/>
           <p:cNvSpPr txBox="0"/>
           <p:nvPr/>
         </p:nvSpPr>
         <p:spPr>
           <a:xfrm>
-            <a:off x="0" y="0"/>
-            <a:ext cx="9525" cy="9525"/>
+            <a:off x="0" y="4762500"/>
+            <a:ext cx="3048000" cy="285750"/>
           </a:xfrm>
           <a:prstGeom prst="rect">
             <a:avLst/>
@@ -4136,14 +4136,14 @@
       </p:grpSpPr>
       <p:sp>
         <p:nvSpPr>
-          <p:cNvPr id="17" name="Rectangle 17"/>
+          <p:cNvPr id="2" name="Rectangle 17"/>
           <p:cNvSpPr txBox="0"/>
           <p:nvPr/>
         </p:nvSpPr>
         <p:spPr>
           <a:xfrm>
-            <a:off x="0" y="0"/>
-            <a:ext cx="9525" cy="9525"/>
+            <a:off x="0" y="4762500"/>
+            <a:ext cx="3048000" cy="285750"/>
           </a:xfrm>
           <a:prstGeom prst="rect">
             <a:avLst/>
@@ -4206,14 +4206,14 @@
       </p:grpSpPr>
       <p:sp>
         <p:nvSpPr>
-          <p:cNvPr id="18" name="Rectangle 18"/>
+          <p:cNvPr id="2" name="Rectangle 18"/>
           <p:cNvSpPr txBox="0"/>
           <p:nvPr/>
         </p:nvSpPr>
         <p:spPr>
           <a:xfrm>
-            <a:off x="0" y="0"/>
-            <a:ext cx="9525" cy="9525"/>
+            <a:off x="0" y="4762500"/>
+            <a:ext cx="3048000" cy="285750"/>
           </a:xfrm>
           <a:prstGeom prst="rect">
             <a:avLst/>
@@ -4276,14 +4276,14 @@
       </p:grpSpPr>
       <p:sp>
         <p:nvSpPr>
-          <p:cNvPr id="19" name="Rectangle 19"/>
+          <p:cNvPr id="2" name="Rectangle 19"/>
           <p:cNvSpPr txBox="0"/>
           <p:nvPr/>
         </p:nvSpPr>
         <p:spPr>
           <a:xfrm>
-            <a:off x="0" y="0"/>
-            <a:ext cx="9525" cy="9525"/>
+            <a:off x="0" y="4762500"/>
+            <a:ext cx="3048000" cy="285750"/>
           </a:xfrm>
           <a:prstGeom prst="rect">
             <a:avLst/>
@@ -4352,8 +4352,8 @@
         </p:nvSpPr>
         <p:spPr>
           <a:xfrm>
-            <a:off x="0" y="0"/>
-            <a:ext cx="9525" cy="9525"/>
+            <a:off x="0" y="4762500"/>
+            <a:ext cx="3048000" cy="285750"/>
           </a:xfrm>
           <a:prstGeom prst="rect">
             <a:avLst/>
@@ -4416,14 +4416,14 @@
       </p:grpSpPr>
       <p:sp>
         <p:nvSpPr>
-          <p:cNvPr id="20" name="Rectangle 20"/>
+          <p:cNvPr id="2" name="Rectangle 20"/>
           <p:cNvSpPr txBox="0"/>
           <p:nvPr/>
         </p:nvSpPr>
         <p:spPr>
           <a:xfrm>
-            <a:off x="0" y="0"/>
-            <a:ext cx="9525" cy="9525"/>
+            <a:off x="0" y="4762500"/>
+            <a:ext cx="3048000" cy="285750"/>
           </a:xfrm>
           <a:prstGeom prst="rect">
             <a:avLst/>
@@ -4486,14 +4486,14 @@
       </p:grpSpPr>
       <p:sp>
         <p:nvSpPr>
-          <p:cNvPr id="3" name="Rectangle 3"/>
+          <p:cNvPr id="2" name="Rectangle 3"/>
           <p:cNvSpPr txBox="0"/>
           <p:nvPr/>
         </p:nvSpPr>
         <p:spPr>
           <a:xfrm>
-            <a:off x="0" y="0"/>
-            <a:ext cx="9525" cy="9525"/>
+            <a:off x="0" y="4762500"/>
+            <a:ext cx="3048000" cy="285750"/>
           </a:xfrm>
           <a:prstGeom prst="rect">
             <a:avLst/>
@@ -4556,14 +4556,14 @@
       </p:grpSpPr>
       <p:sp>
         <p:nvSpPr>
-          <p:cNvPr id="4" name="Rectangle 4"/>
+          <p:cNvPr id="2" name="Rectangle 4"/>
           <p:cNvSpPr txBox="0"/>
           <p:nvPr/>
         </p:nvSpPr>
         <p:spPr>
           <a:xfrm>
-            <a:off x="0" y="0"/>
-            <a:ext cx="9525" cy="9525"/>
+            <a:off x="0" y="4762500"/>
+            <a:ext cx="3048000" cy="285750"/>
           </a:xfrm>
           <a:prstGeom prst="rect">
             <a:avLst/>
@@ -4626,14 +4626,14 @@
       </p:grpSpPr>
       <p:sp>
         <p:nvSpPr>
-          <p:cNvPr id="5" name="Rectangle 5"/>
+          <p:cNvPr id="2" name="Rectangle 5"/>
           <p:cNvSpPr txBox="0"/>
           <p:nvPr/>
         </p:nvSpPr>
         <p:spPr>
           <a:xfrm>
-            <a:off x="0" y="0"/>
-            <a:ext cx="9525" cy="9525"/>
+            <a:off x="0" y="4762500"/>
+            <a:ext cx="3048000" cy="285750"/>
           </a:xfrm>
           <a:prstGeom prst="rect">
             <a:avLst/>
@@ -4696,14 +4696,14 @@
       </p:grpSpPr>
       <p:sp>
         <p:nvSpPr>
-          <p:cNvPr id="6" name="Rectangle 6"/>
+          <p:cNvPr id="2" name="Rectangle 6"/>
           <p:cNvSpPr txBox="0"/>
           <p:nvPr/>
         </p:nvSpPr>
         <p:spPr>
           <a:xfrm>
-            <a:off x="0" y="0"/>
-            <a:ext cx="9525" cy="9525"/>
+            <a:off x="0" y="4762500"/>
+            <a:ext cx="3048000" cy="285750"/>
           </a:xfrm>
           <a:prstGeom prst="rect">
             <a:avLst/>
@@ -4766,14 +4766,14 @@
       </p:grpSpPr>
       <p:sp>
         <p:nvSpPr>
-          <p:cNvPr id="7" name="Rectangle 7"/>
+          <p:cNvPr id="2" name="Rectangle 7"/>
           <p:cNvSpPr txBox="0"/>
           <p:nvPr/>
         </p:nvSpPr>
         <p:spPr>
           <a:xfrm>
-            <a:off x="0" y="0"/>
-            <a:ext cx="9525" cy="9525"/>
+            <a:off x="0" y="4762500"/>
+            <a:ext cx="3048000" cy="285750"/>
           </a:xfrm>
           <a:prstGeom prst="rect">
             <a:avLst/>
@@ -4836,14 +4836,14 @@
       </p:grpSpPr>
       <p:sp>
         <p:nvSpPr>
-          <p:cNvPr id="8" name="Rectangle 8"/>
+          <p:cNvPr id="2" name="Rectangle 8"/>
           <p:cNvSpPr txBox="0"/>
           <p:nvPr/>
         </p:nvSpPr>
         <p:spPr>
           <a:xfrm>
-            <a:off x="0" y="0"/>
-            <a:ext cx="9525" cy="9525"/>
+            <a:off x="0" y="4762500"/>
+            <a:ext cx="3048000" cy="285750"/>
           </a:xfrm>
           <a:prstGeom prst="rect">
             <a:avLst/>
@@ -4906,14 +4906,14 @@
       </p:grpSpPr>
       <p:sp>
         <p:nvSpPr>
-          <p:cNvPr id="9" name="Rectangle 9"/>
+          <p:cNvPr id="2" name="Rectangle 9"/>
           <p:cNvSpPr txBox="0"/>
           <p:nvPr/>
         </p:nvSpPr>
         <p:spPr>
           <a:xfrm>
-            <a:off x="0" y="0"/>
-            <a:ext cx="9525" cy="9525"/>
+            <a:off x="0" y="4762500"/>
+            <a:ext cx="3048000" cy="285750"/>
           </a:xfrm>
           <a:prstGeom prst="rect">
             <a:avLst/>

</xml_diff>

<commit_message>
test(e2e): give the box-whisker gallery chart repeated category rows
827b31b76 (COM-verified against charts-com.pptx slide 32) made the
box-whisker renderer treat each cx:boxWhisker row as one observation and
draw one box per (series, unique category), which is how PowerPoint
shapes that data. The gallery fixture still used four unique quarter
labels, so every box had a single observation, computeBoxStats returned
nothing, and only the three chrome rects remained ("<rect> x5 - quartile
boxes: received 3") in every binding.

Author the box-whisker slide with two labels repeated twice, so each of
the three series draws a box in both groups, and assert those six boxes
in chart-rendering.spec.ts instead of the old pooled-by-category count.

Co-Authored-By: Claude Opus 5.5 (1M context) <noreply@anthropic.com>
Claude-Session: https://claude.ai/code/session_019SNjtp8WibuFkSPSc6oLJ9
</commit_message>
<xml_diff>
--- a/viewers/pptx/e2e/fixtures/chart-gallery.pptx
+++ b/viewers/pptx/e2e/fixtures/chart-gallery.pptx
@@ -679,10 +679,10 @@
       <cx:strDim type="cat">
         <cx:f>Sheet1!$A$2:$A$5</cx:f>
         <cx:lvl ptCount="4">
-          <cx:pt idx="0">Q1</cx:pt>
-          <cx:pt idx="1">Q2</cx:pt>
-          <cx:pt idx="2">Q3</cx:pt>
-          <cx:pt idx="3">Q4</cx:pt>
+          <cx:pt idx="0">Group A</cx:pt>
+          <cx:pt idx="1">Group A</cx:pt>
+          <cx:pt idx="2">Group B</cx:pt>
+          <cx:pt idx="3">Group B</cx:pt>
         </cx:lvl>
       </cx:strDim>
       <cx:numDim type="val">
@@ -699,10 +699,10 @@
       <cx:strDim type="cat">
         <cx:f>Sheet1!$A$2:$A$5</cx:f>
         <cx:lvl ptCount="4">
-          <cx:pt idx="0">Q1</cx:pt>
-          <cx:pt idx="1">Q2</cx:pt>
-          <cx:pt idx="2">Q3</cx:pt>
-          <cx:pt idx="3">Q4</cx:pt>
+          <cx:pt idx="0">Group A</cx:pt>
+          <cx:pt idx="1">Group A</cx:pt>
+          <cx:pt idx="2">Group B</cx:pt>
+          <cx:pt idx="3">Group B</cx:pt>
         </cx:lvl>
       </cx:strDim>
       <cx:numDim type="val">
@@ -719,10 +719,10 @@
       <cx:strDim type="cat">
         <cx:f>Sheet1!$A$2:$A$5</cx:f>
         <cx:lvl ptCount="4">
-          <cx:pt idx="0">Q1</cx:pt>
-          <cx:pt idx="1">Q2</cx:pt>
-          <cx:pt idx="2">Q3</cx:pt>
-          <cx:pt idx="3">Q4</cx:pt>
+          <cx:pt idx="0">Group A</cx:pt>
+          <cx:pt idx="1">Group A</cx:pt>
+          <cx:pt idx="2">Group B</cx:pt>
+          <cx:pt idx="3">Group B</cx:pt>
         </cx:lvl>
       </cx:strDim>
       <cx:numDim type="val">
@@ -3594,12 +3594,10 @@
           <a:bodyPr wrap="square"/>
           <a:lstStyle/>
           <a:p>
-            <a:pPr/>
             <a:r>
               <a:rPr lang="en-US" dirty="0"/>
               <a:t>Clustered Bar</a:t>
             </a:r>
-            <a:endParaRPr lang="en-US"/>
           </a:p>
         </p:txBody>
       </p:sp>
@@ -3664,12 +3662,10 @@
           <a:bodyPr wrap="square"/>
           <a:lstStyle/>
           <a:p>
-            <a:pPr/>
             <a:r>
               <a:rPr lang="en-US" dirty="0"/>
               <a:t>Percent Stacked Bar</a:t>
             </a:r>
-            <a:endParaRPr lang="en-US"/>
           </a:p>
         </p:txBody>
       </p:sp>
@@ -3734,12 +3730,10 @@
           <a:bodyPr wrap="square"/>
           <a:lstStyle/>
           <a:p>
-            <a:pPr/>
             <a:r>
               <a:rPr lang="en-US" dirty="0"/>
               <a:t>Funnel</a:t>
             </a:r>
-            <a:endParaRPr lang="en-US"/>
           </a:p>
         </p:txBody>
       </p:sp>
@@ -3804,12 +3798,10 @@
           <a:bodyPr wrap="square"/>
           <a:lstStyle/>
           <a:p>
-            <a:pPr/>
             <a:r>
               <a:rPr lang="en-US" dirty="0"/>
               <a:t>Sunburst</a:t>
             </a:r>
-            <a:endParaRPr lang="en-US"/>
           </a:p>
         </p:txBody>
       </p:sp>
@@ -3874,12 +3866,10 @@
           <a:bodyPr wrap="square"/>
           <a:lstStyle/>
           <a:p>
-            <a:pPr/>
             <a:r>
               <a:rPr lang="en-US" dirty="0"/>
               <a:t>Histogram</a:t>
             </a:r>
-            <a:endParaRPr lang="en-US"/>
           </a:p>
         </p:txBody>
       </p:sp>
@@ -3944,12 +3934,10 @@
           <a:bodyPr wrap="square"/>
           <a:lstStyle/>
           <a:p>
-            <a:pPr/>
             <a:r>
               <a:rPr lang="en-US" dirty="0"/>
               <a:t>Box-Whisker</a:t>
             </a:r>
-            <a:endParaRPr lang="en-US"/>
           </a:p>
         </p:txBody>
       </p:sp>
@@ -4014,12 +4002,10 @@
           <a:bodyPr wrap="square"/>
           <a:lstStyle/>
           <a:p>
-            <a:pPr/>
             <a:r>
               <a:rPr lang="en-US" dirty="0"/>
               <a:t>Combo</a:t>
             </a:r>
-            <a:endParaRPr lang="en-US"/>
           </a:p>
         </p:txBody>
       </p:sp>
@@ -4084,12 +4070,10 @@
           <a:bodyPr wrap="square"/>
           <a:lstStyle/>
           <a:p>
-            <a:pPr/>
             <a:r>
               <a:rPr lang="en-US" dirty="0"/>
               <a:t>Stock</a:t>
             </a:r>
-            <a:endParaRPr lang="en-US"/>
           </a:p>
         </p:txBody>
       </p:sp>
@@ -4154,12 +4138,10 @@
           <a:bodyPr wrap="square"/>
           <a:lstStyle/>
           <a:p>
-            <a:pPr/>
             <a:r>
               <a:rPr lang="en-US" dirty="0"/>
               <a:t>Surface</a:t>
             </a:r>
-            <a:endParaRPr lang="en-US"/>
           </a:p>
         </p:txBody>
       </p:sp>
@@ -4224,12 +4206,10 @@
           <a:bodyPr wrap="square"/>
           <a:lstStyle/>
           <a:p>
-            <a:pPr/>
             <a:r>
               <a:rPr lang="en-US" dirty="0"/>
               <a:t>Waterfall</a:t>
             </a:r>
-            <a:endParaRPr lang="en-US"/>
           </a:p>
         </p:txBody>
       </p:sp>
@@ -4294,12 +4274,10 @@
           <a:bodyPr wrap="square"/>
           <a:lstStyle/>
           <a:p>
-            <a:pPr/>
             <a:r>
               <a:rPr lang="en-US" dirty="0"/>
               <a:t>Treemap</a:t>
             </a:r>
-            <a:endParaRPr lang="en-US"/>
           </a:p>
         </p:txBody>
       </p:sp>
@@ -4364,12 +4342,10 @@
           <a:bodyPr wrap="square"/>
           <a:lstStyle/>
           <a:p>
-            <a:pPr/>
             <a:r>
               <a:rPr lang="en-US" dirty="0"/>
               <a:t>Line (with trendline)</a:t>
             </a:r>
-            <a:endParaRPr lang="en-US"/>
           </a:p>
         </p:txBody>
       </p:sp>
@@ -4434,12 +4410,10 @@
           <a:bodyPr wrap="square"/>
           <a:lstStyle/>
           <a:p>
-            <a:pPr/>
             <a:r>
               <a:rPr lang="en-US" dirty="0"/>
               <a:t>Region Map</a:t>
             </a:r>
-            <a:endParaRPr lang="en-US"/>
           </a:p>
         </p:txBody>
       </p:sp>
@@ -4504,12 +4478,10 @@
           <a:bodyPr wrap="square"/>
           <a:lstStyle/>
           <a:p>
-            <a:pPr/>
             <a:r>
               <a:rPr lang="en-US" dirty="0"/>
               <a:t>Area</a:t>
             </a:r>
-            <a:endParaRPr lang="en-US"/>
           </a:p>
         </p:txBody>
       </p:sp>
@@ -4574,12 +4546,10 @@
           <a:bodyPr wrap="square"/>
           <a:lstStyle/>
           <a:p>
-            <a:pPr/>
             <a:r>
               <a:rPr lang="en-US" dirty="0"/>
               <a:t>Pie</a:t>
             </a:r>
-            <a:endParaRPr lang="en-US"/>
           </a:p>
         </p:txBody>
       </p:sp>
@@ -4644,12 +4614,10 @@
           <a:bodyPr wrap="square"/>
           <a:lstStyle/>
           <a:p>
-            <a:pPr/>
             <a:r>
               <a:rPr lang="en-US" dirty="0"/>
               <a:t>Doughnut</a:t>
             </a:r>
-            <a:endParaRPr lang="en-US"/>
           </a:p>
         </p:txBody>
       </p:sp>
@@ -4714,12 +4682,10 @@
           <a:bodyPr wrap="square"/>
           <a:lstStyle/>
           <a:p>
-            <a:pPr/>
             <a:r>
               <a:rPr lang="en-US" dirty="0"/>
               <a:t>Radar</a:t>
             </a:r>
-            <a:endParaRPr lang="en-US"/>
           </a:p>
         </p:txBody>
       </p:sp>
@@ -4784,12 +4750,10 @@
           <a:bodyPr wrap="square"/>
           <a:lstStyle/>
           <a:p>
-            <a:pPr/>
             <a:r>
               <a:rPr lang="en-US" dirty="0"/>
               <a:t>Scatter</a:t>
             </a:r>
-            <a:endParaRPr lang="en-US"/>
           </a:p>
         </p:txBody>
       </p:sp>
@@ -4854,12 +4818,10 @@
           <a:bodyPr wrap="square"/>
           <a:lstStyle/>
           <a:p>
-            <a:pPr/>
             <a:r>
               <a:rPr lang="en-US" dirty="0"/>
               <a:t>Bubble</a:t>
             </a:r>
-            <a:endParaRPr lang="en-US"/>
           </a:p>
         </p:txBody>
       </p:sp>
@@ -4924,12 +4886,10 @@
           <a:bodyPr wrap="square"/>
           <a:lstStyle/>
           <a:p>
-            <a:pPr/>
             <a:r>
               <a:rPr lang="en-US" dirty="0"/>
               <a:t>Stacked Bar</a:t>
             </a:r>
-            <a:endParaRPr lang="en-US"/>
           </a:p>
         </p:txBody>
       </p:sp>

</xml_diff>